<commit_message>
Make healthcare demo bulletproof for cold walkthroughs
- Dismiss onboarding banner (demo data is already loaded)
- Pre-populate audit log, procedure log, jeopardy assignments
- Add future shifts so Resident My Schedule tab has content
- Fix nurse PTO/Sick showing dashes (show realistic values)
- Fix all nested buttons via session_state persistence
- Nursing generate, sick call assign, physician find, year schedule
</commit_message>
<xml_diff>
--- a/docs/ShiftGuard_Healthcare_Pitch.pptx
+++ b/docs/ShiftGuard_Healthcare_Pitch.pptx
@@ -5,22 +5,22 @@
     <p:sldMasterId id="2147483648" r:id="rId1"/>
   </p:sldMasterIdLst>
   <p:sldIdLst>
-    <p:sldId id="256" r:id="rId7"/>
-    <p:sldId id="257" r:id="rId8"/>
-    <p:sldId id="258" r:id="rId9"/>
-    <p:sldId id="259" r:id="rId10"/>
-    <p:sldId id="260" r:id="rId11"/>
-    <p:sldId id="261" r:id="rId12"/>
-    <p:sldId id="262" r:id="rId13"/>
-    <p:sldId id="263" r:id="rId14"/>
-    <p:sldId id="264" r:id="rId15"/>
-    <p:sldId id="265" r:id="rId16"/>
-    <p:sldId id="266" r:id="rId17"/>
-    <p:sldId id="267" r:id="rId18"/>
-    <p:sldId id="268" r:id="rId19"/>
-    <p:sldId id="269" r:id="rId20"/>
+    <p:sldId id="256" r:id="rId2"/>
+    <p:sldId id="257" r:id="rId3"/>
+    <p:sldId id="258" r:id="rId4"/>
+    <p:sldId id="259" r:id="rId5"/>
+    <p:sldId id="260" r:id="rId6"/>
+    <p:sldId id="261" r:id="rId7"/>
+    <p:sldId id="262" r:id="rId8"/>
+    <p:sldId id="263" r:id="rId9"/>
+    <p:sldId id="264" r:id="rId10"/>
+    <p:sldId id="265" r:id="rId11"/>
+    <p:sldId id="266" r:id="rId12"/>
+    <p:sldId id="267" r:id="rId13"/>
+    <p:sldId id="268" r:id="rId14"/>
+    <p:sldId id="269" r:id="rId15"/>
   </p:sldIdLst>
-  <p:sldSz cx="12191695" cy="6858000" type="screen4x3"/>
+  <p:sldSz cx="12192000" cy="6858000"/>
   <p:notesSz cx="6858000" cy="9144000"/>
   <p:defaultTextStyle>
     <a:defPPr>
@@ -117,6 +117,22 @@
       </a:defRPr>
     </a:lvl9pPr>
   </p:defaultTextStyle>
+  <p:extLst>
+    <p:ext uri="{EFAFB233-063F-42B5-8137-9DF3F51BA10A}">
+      <p15:sldGuideLst xmlns:p15="http://schemas.microsoft.com/office/powerpoint/2012/main">
+        <p15:guide id="1" orient="horz" pos="2160">
+          <p15:clr>
+            <a:srgbClr val="A4A3A4"/>
+          </p15:clr>
+        </p15:guide>
+        <p15:guide id="2" pos="2880">
+          <p15:clr>
+            <a:srgbClr val="A4A3A4"/>
+          </p15:clr>
+        </p15:guide>
+      </p15:sldGuideLst>
+    </p:ext>
+  </p:extLst>
 </p:presentation>
 </file>
 
@@ -158,10 +174,9 @@
           <a:lstStyle/>
           <a:p>
             <a:r>
-              <a:rPr lang="en-US" smtClean="0"/>
+              <a:rPr lang="en-US"/>
               <a:t>Click to edit Master title style</a:t>
             </a:r>
-            <a:endParaRPr lang="en-US"/>
           </a:p>
         </p:txBody>
       </p:sp>
@@ -277,10 +292,9 @@
           </a:lstStyle>
           <a:p>
             <a:r>
-              <a:rPr lang="en-US" smtClean="0"/>
+              <a:rPr lang="en-US"/>
               <a:t>Click to edit Master subtitle style</a:t>
             </a:r>
-            <a:endParaRPr lang="en-US"/>
           </a:p>
         </p:txBody>
       </p:sp>
@@ -301,7 +315,7 @@
           <a:p>
             <a:fld id="{5BCAD085-E8A6-8845-BD4E-CB4CCA059FC4}" type="datetimeFigureOut">
               <a:rPr lang="en-US" smtClean="0"/>
-              <a:t>1/27/13</a:t>
+              <a:t>7/8/2026</a:t>
             </a:fld>
             <a:endParaRPr lang="en-US"/>
           </a:p>
@@ -395,10 +409,9 @@
           <a:lstStyle/>
           <a:p>
             <a:r>
-              <a:rPr lang="en-US" smtClean="0"/>
+              <a:rPr lang="en-US"/>
               <a:t>Click to edit Master title style</a:t>
             </a:r>
-            <a:endParaRPr lang="en-US"/>
           </a:p>
         </p:txBody>
       </p:sp>
@@ -419,38 +432,37 @@
           <a:p>
             <a:pPr lvl="0"/>
             <a:r>
-              <a:rPr lang="en-US" smtClean="0"/>
+              <a:rPr lang="en-US"/>
               <a:t>Click to edit Master text styles</a:t>
             </a:r>
           </a:p>
           <a:p>
             <a:pPr lvl="1"/>
             <a:r>
-              <a:rPr lang="en-US" smtClean="0"/>
+              <a:rPr lang="en-US"/>
               <a:t>Second level</a:t>
             </a:r>
           </a:p>
           <a:p>
             <a:pPr lvl="2"/>
             <a:r>
-              <a:rPr lang="en-US" smtClean="0"/>
+              <a:rPr lang="en-US"/>
               <a:t>Third level</a:t>
             </a:r>
           </a:p>
           <a:p>
             <a:pPr lvl="3"/>
             <a:r>
-              <a:rPr lang="en-US" smtClean="0"/>
+              <a:rPr lang="en-US"/>
               <a:t>Fourth level</a:t>
             </a:r>
           </a:p>
           <a:p>
             <a:pPr lvl="4"/>
             <a:r>
-              <a:rPr lang="en-US" smtClean="0"/>
+              <a:rPr lang="en-US"/>
               <a:t>Fifth level</a:t>
             </a:r>
-            <a:endParaRPr lang="en-US"/>
           </a:p>
         </p:txBody>
       </p:sp>
@@ -471,7 +483,7 @@
           <a:p>
             <a:fld id="{5BCAD085-E8A6-8845-BD4E-CB4CCA059FC4}" type="datetimeFigureOut">
               <a:rPr lang="en-US" smtClean="0"/>
-              <a:t>1/27/13</a:t>
+              <a:t>7/8/2026</a:t>
             </a:fld>
             <a:endParaRPr lang="en-US"/>
           </a:p>
@@ -570,10 +582,9 @@
           <a:lstStyle/>
           <a:p>
             <a:r>
-              <a:rPr lang="en-US" smtClean="0"/>
+              <a:rPr lang="en-US"/>
               <a:t>Click to edit Master title style</a:t>
             </a:r>
-            <a:endParaRPr lang="en-US"/>
           </a:p>
         </p:txBody>
       </p:sp>
@@ -599,38 +610,37 @@
           <a:p>
             <a:pPr lvl="0"/>
             <a:r>
-              <a:rPr lang="en-US" smtClean="0"/>
+              <a:rPr lang="en-US"/>
               <a:t>Click to edit Master text styles</a:t>
             </a:r>
           </a:p>
           <a:p>
             <a:pPr lvl="1"/>
             <a:r>
-              <a:rPr lang="en-US" smtClean="0"/>
+              <a:rPr lang="en-US"/>
               <a:t>Second level</a:t>
             </a:r>
           </a:p>
           <a:p>
             <a:pPr lvl="2"/>
             <a:r>
-              <a:rPr lang="en-US" smtClean="0"/>
+              <a:rPr lang="en-US"/>
               <a:t>Third level</a:t>
             </a:r>
           </a:p>
           <a:p>
             <a:pPr lvl="3"/>
             <a:r>
-              <a:rPr lang="en-US" smtClean="0"/>
+              <a:rPr lang="en-US"/>
               <a:t>Fourth level</a:t>
             </a:r>
           </a:p>
           <a:p>
             <a:pPr lvl="4"/>
             <a:r>
-              <a:rPr lang="en-US" smtClean="0"/>
+              <a:rPr lang="en-US"/>
               <a:t>Fifth level</a:t>
             </a:r>
-            <a:endParaRPr lang="en-US"/>
           </a:p>
         </p:txBody>
       </p:sp>
@@ -651,7 +661,7 @@
           <a:p>
             <a:fld id="{5BCAD085-E8A6-8845-BD4E-CB4CCA059FC4}" type="datetimeFigureOut">
               <a:rPr lang="en-US" smtClean="0"/>
-              <a:t>1/27/13</a:t>
+              <a:t>7/8/2026</a:t>
             </a:fld>
             <a:endParaRPr lang="en-US"/>
           </a:p>
@@ -745,10 +755,9 @@
           <a:lstStyle/>
           <a:p>
             <a:r>
-              <a:rPr lang="en-US" smtClean="0"/>
+              <a:rPr lang="en-US"/>
               <a:t>Click to edit Master title style</a:t>
             </a:r>
-            <a:endParaRPr lang="en-US"/>
           </a:p>
         </p:txBody>
       </p:sp>
@@ -769,38 +778,37 @@
           <a:p>
             <a:pPr lvl="0"/>
             <a:r>
-              <a:rPr lang="en-US" smtClean="0"/>
+              <a:rPr lang="en-US"/>
               <a:t>Click to edit Master text styles</a:t>
             </a:r>
           </a:p>
           <a:p>
             <a:pPr lvl="1"/>
             <a:r>
-              <a:rPr lang="en-US" smtClean="0"/>
+              <a:rPr lang="en-US"/>
               <a:t>Second level</a:t>
             </a:r>
           </a:p>
           <a:p>
             <a:pPr lvl="2"/>
             <a:r>
-              <a:rPr lang="en-US" smtClean="0"/>
+              <a:rPr lang="en-US"/>
               <a:t>Third level</a:t>
             </a:r>
           </a:p>
           <a:p>
             <a:pPr lvl="3"/>
             <a:r>
-              <a:rPr lang="en-US" smtClean="0"/>
+              <a:rPr lang="en-US"/>
               <a:t>Fourth level</a:t>
             </a:r>
           </a:p>
           <a:p>
             <a:pPr lvl="4"/>
             <a:r>
-              <a:rPr lang="en-US" smtClean="0"/>
+              <a:rPr lang="en-US"/>
               <a:t>Fifth level</a:t>
             </a:r>
-            <a:endParaRPr lang="en-US"/>
           </a:p>
         </p:txBody>
       </p:sp>
@@ -821,7 +829,7 @@
           <a:p>
             <a:fld id="{5BCAD085-E8A6-8845-BD4E-CB4CCA059FC4}" type="datetimeFigureOut">
               <a:rPr lang="en-US" smtClean="0"/>
-              <a:t>1/27/13</a:t>
+              <a:t>7/8/2026</a:t>
             </a:fld>
             <a:endParaRPr lang="en-US"/>
           </a:p>
@@ -924,10 +932,9 @@
           </a:lstStyle>
           <a:p>
             <a:r>
-              <a:rPr lang="en-US" smtClean="0"/>
+              <a:rPr lang="en-US"/>
               <a:t>Click to edit Master title style</a:t>
             </a:r>
-            <a:endParaRPr lang="en-US"/>
           </a:p>
         </p:txBody>
       </p:sp>
@@ -1044,7 +1051,7 @@
           <a:p>
             <a:pPr lvl="0"/>
             <a:r>
-              <a:rPr lang="en-US" smtClean="0"/>
+              <a:rPr lang="en-US"/>
               <a:t>Click to edit Master text styles</a:t>
             </a:r>
           </a:p>
@@ -1067,7 +1074,7 @@
           <a:p>
             <a:fld id="{5BCAD085-E8A6-8845-BD4E-CB4CCA059FC4}" type="datetimeFigureOut">
               <a:rPr lang="en-US" smtClean="0"/>
-              <a:t>1/27/13</a:t>
+              <a:t>7/8/2026</a:t>
             </a:fld>
             <a:endParaRPr lang="en-US"/>
           </a:p>
@@ -1161,10 +1168,9 @@
           <a:lstStyle/>
           <a:p>
             <a:r>
-              <a:rPr lang="en-US" smtClean="0"/>
+              <a:rPr lang="en-US"/>
               <a:t>Click to edit Master title style</a:t>
             </a:r>
-            <a:endParaRPr lang="en-US"/>
           </a:p>
         </p:txBody>
       </p:sp>
@@ -1218,38 +1224,37 @@
           <a:p>
             <a:pPr lvl="0"/>
             <a:r>
-              <a:rPr lang="en-US" smtClean="0"/>
+              <a:rPr lang="en-US"/>
               <a:t>Click to edit Master text styles</a:t>
             </a:r>
           </a:p>
           <a:p>
             <a:pPr lvl="1"/>
             <a:r>
-              <a:rPr lang="en-US" smtClean="0"/>
+              <a:rPr lang="en-US"/>
               <a:t>Second level</a:t>
             </a:r>
           </a:p>
           <a:p>
             <a:pPr lvl="2"/>
             <a:r>
-              <a:rPr lang="en-US" smtClean="0"/>
+              <a:rPr lang="en-US"/>
               <a:t>Third level</a:t>
             </a:r>
           </a:p>
           <a:p>
             <a:pPr lvl="3"/>
             <a:r>
-              <a:rPr lang="en-US" smtClean="0"/>
+              <a:rPr lang="en-US"/>
               <a:t>Fourth level</a:t>
             </a:r>
           </a:p>
           <a:p>
             <a:pPr lvl="4"/>
             <a:r>
-              <a:rPr lang="en-US" smtClean="0"/>
+              <a:rPr lang="en-US"/>
               <a:t>Fifth level</a:t>
             </a:r>
-            <a:endParaRPr lang="en-US"/>
           </a:p>
         </p:txBody>
       </p:sp>
@@ -1303,38 +1308,37 @@
           <a:p>
             <a:pPr lvl="0"/>
             <a:r>
-              <a:rPr lang="en-US" smtClean="0"/>
+              <a:rPr lang="en-US"/>
               <a:t>Click to edit Master text styles</a:t>
             </a:r>
           </a:p>
           <a:p>
             <a:pPr lvl="1"/>
             <a:r>
-              <a:rPr lang="en-US" smtClean="0"/>
+              <a:rPr lang="en-US"/>
               <a:t>Second level</a:t>
             </a:r>
           </a:p>
           <a:p>
             <a:pPr lvl="2"/>
             <a:r>
-              <a:rPr lang="en-US" smtClean="0"/>
+              <a:rPr lang="en-US"/>
               <a:t>Third level</a:t>
             </a:r>
           </a:p>
           <a:p>
             <a:pPr lvl="3"/>
             <a:r>
-              <a:rPr lang="en-US" smtClean="0"/>
+              <a:rPr lang="en-US"/>
               <a:t>Fourth level</a:t>
             </a:r>
           </a:p>
           <a:p>
             <a:pPr lvl="4"/>
             <a:r>
-              <a:rPr lang="en-US" smtClean="0"/>
+              <a:rPr lang="en-US"/>
               <a:t>Fifth level</a:t>
             </a:r>
-            <a:endParaRPr lang="en-US"/>
           </a:p>
         </p:txBody>
       </p:sp>
@@ -1355,7 +1359,7 @@
           <a:p>
             <a:fld id="{5BCAD085-E8A6-8845-BD4E-CB4CCA059FC4}" type="datetimeFigureOut">
               <a:rPr lang="en-US" smtClean="0"/>
-              <a:t>1/27/13</a:t>
+              <a:t>7/8/2026</a:t>
             </a:fld>
             <a:endParaRPr lang="en-US"/>
           </a:p>
@@ -1453,10 +1457,9 @@
           </a:lstStyle>
           <a:p>
             <a:r>
-              <a:rPr lang="en-US" smtClean="0"/>
+              <a:rPr lang="en-US"/>
               <a:t>Click to edit Master title style</a:t>
             </a:r>
-            <a:endParaRPr lang="en-US"/>
           </a:p>
         </p:txBody>
       </p:sp>
@@ -1519,7 +1522,7 @@
           <a:p>
             <a:pPr lvl="0"/>
             <a:r>
-              <a:rPr lang="en-US" smtClean="0"/>
+              <a:rPr lang="en-US"/>
               <a:t>Click to edit Master text styles</a:t>
             </a:r>
           </a:p>
@@ -1575,38 +1578,37 @@
           <a:p>
             <a:pPr lvl="0"/>
             <a:r>
-              <a:rPr lang="en-US" smtClean="0"/>
+              <a:rPr lang="en-US"/>
               <a:t>Click to edit Master text styles</a:t>
             </a:r>
           </a:p>
           <a:p>
             <a:pPr lvl="1"/>
             <a:r>
-              <a:rPr lang="en-US" smtClean="0"/>
+              <a:rPr lang="en-US"/>
               <a:t>Second level</a:t>
             </a:r>
           </a:p>
           <a:p>
             <a:pPr lvl="2"/>
             <a:r>
-              <a:rPr lang="en-US" smtClean="0"/>
+              <a:rPr lang="en-US"/>
               <a:t>Third level</a:t>
             </a:r>
           </a:p>
           <a:p>
             <a:pPr lvl="3"/>
             <a:r>
-              <a:rPr lang="en-US" smtClean="0"/>
+              <a:rPr lang="en-US"/>
               <a:t>Fourth level</a:t>
             </a:r>
           </a:p>
           <a:p>
             <a:pPr lvl="4"/>
             <a:r>
-              <a:rPr lang="en-US" smtClean="0"/>
+              <a:rPr lang="en-US"/>
               <a:t>Fifth level</a:t>
             </a:r>
-            <a:endParaRPr lang="en-US"/>
           </a:p>
         </p:txBody>
       </p:sp>
@@ -1669,7 +1671,7 @@
           <a:p>
             <a:pPr lvl="0"/>
             <a:r>
-              <a:rPr lang="en-US" smtClean="0"/>
+              <a:rPr lang="en-US"/>
               <a:t>Click to edit Master text styles</a:t>
             </a:r>
           </a:p>
@@ -1725,38 +1727,37 @@
           <a:p>
             <a:pPr lvl="0"/>
             <a:r>
-              <a:rPr lang="en-US" smtClean="0"/>
+              <a:rPr lang="en-US"/>
               <a:t>Click to edit Master text styles</a:t>
             </a:r>
           </a:p>
           <a:p>
             <a:pPr lvl="1"/>
             <a:r>
-              <a:rPr lang="en-US" smtClean="0"/>
+              <a:rPr lang="en-US"/>
               <a:t>Second level</a:t>
             </a:r>
           </a:p>
           <a:p>
             <a:pPr lvl="2"/>
             <a:r>
-              <a:rPr lang="en-US" smtClean="0"/>
+              <a:rPr lang="en-US"/>
               <a:t>Third level</a:t>
             </a:r>
           </a:p>
           <a:p>
             <a:pPr lvl="3"/>
             <a:r>
-              <a:rPr lang="en-US" smtClean="0"/>
+              <a:rPr lang="en-US"/>
               <a:t>Fourth level</a:t>
             </a:r>
           </a:p>
           <a:p>
             <a:pPr lvl="4"/>
             <a:r>
-              <a:rPr lang="en-US" smtClean="0"/>
+              <a:rPr lang="en-US"/>
               <a:t>Fifth level</a:t>
             </a:r>
-            <a:endParaRPr lang="en-US"/>
           </a:p>
         </p:txBody>
       </p:sp>
@@ -1777,7 +1778,7 @@
           <a:p>
             <a:fld id="{5BCAD085-E8A6-8845-BD4E-CB4CCA059FC4}" type="datetimeFigureOut">
               <a:rPr lang="en-US" smtClean="0"/>
-              <a:t>1/27/13</a:t>
+              <a:t>7/8/2026</a:t>
             </a:fld>
             <a:endParaRPr lang="en-US"/>
           </a:p>
@@ -1871,10 +1872,9 @@
           <a:lstStyle/>
           <a:p>
             <a:r>
-              <a:rPr lang="en-US" smtClean="0"/>
+              <a:rPr lang="en-US"/>
               <a:t>Click to edit Master title style</a:t>
             </a:r>
-            <a:endParaRPr lang="en-US"/>
           </a:p>
         </p:txBody>
       </p:sp>
@@ -1895,7 +1895,7 @@
           <a:p>
             <a:fld id="{5BCAD085-E8A6-8845-BD4E-CB4CCA059FC4}" type="datetimeFigureOut">
               <a:rPr lang="en-US" smtClean="0"/>
-              <a:t>1/27/13</a:t>
+              <a:t>7/8/2026</a:t>
             </a:fld>
             <a:endParaRPr lang="en-US"/>
           </a:p>
@@ -1990,7 +1990,7 @@
           <a:p>
             <a:fld id="{5BCAD085-E8A6-8845-BD4E-CB4CCA059FC4}" type="datetimeFigureOut">
               <a:rPr lang="en-US" smtClean="0"/>
-              <a:t>1/27/13</a:t>
+              <a:t>7/8/2026</a:t>
             </a:fld>
             <a:endParaRPr lang="en-US"/>
           </a:p>
@@ -2093,10 +2093,9 @@
           </a:lstStyle>
           <a:p>
             <a:r>
-              <a:rPr lang="en-US" smtClean="0"/>
+              <a:rPr lang="en-US"/>
               <a:t>Click to edit Master title style</a:t>
             </a:r>
-            <a:endParaRPr lang="en-US"/>
           </a:p>
         </p:txBody>
       </p:sp>
@@ -2150,38 +2149,37 @@
           <a:p>
             <a:pPr lvl="0"/>
             <a:r>
-              <a:rPr lang="en-US" smtClean="0"/>
+              <a:rPr lang="en-US"/>
               <a:t>Click to edit Master text styles</a:t>
             </a:r>
           </a:p>
           <a:p>
             <a:pPr lvl="1"/>
             <a:r>
-              <a:rPr lang="en-US" smtClean="0"/>
+              <a:rPr lang="en-US"/>
               <a:t>Second level</a:t>
             </a:r>
           </a:p>
           <a:p>
             <a:pPr lvl="2"/>
             <a:r>
-              <a:rPr lang="en-US" smtClean="0"/>
+              <a:rPr lang="en-US"/>
               <a:t>Third level</a:t>
             </a:r>
           </a:p>
           <a:p>
             <a:pPr lvl="3"/>
             <a:r>
-              <a:rPr lang="en-US" smtClean="0"/>
+              <a:rPr lang="en-US"/>
               <a:t>Fourth level</a:t>
             </a:r>
           </a:p>
           <a:p>
             <a:pPr lvl="4"/>
             <a:r>
-              <a:rPr lang="en-US" smtClean="0"/>
+              <a:rPr lang="en-US"/>
               <a:t>Fifth level</a:t>
             </a:r>
-            <a:endParaRPr lang="en-US"/>
           </a:p>
         </p:txBody>
       </p:sp>
@@ -2244,7 +2242,7 @@
           <a:p>
             <a:pPr lvl="0"/>
             <a:r>
-              <a:rPr lang="en-US" smtClean="0"/>
+              <a:rPr lang="en-US"/>
               <a:t>Click to edit Master text styles</a:t>
             </a:r>
           </a:p>
@@ -2267,7 +2265,7 @@
           <a:p>
             <a:fld id="{5BCAD085-E8A6-8845-BD4E-CB4CCA059FC4}" type="datetimeFigureOut">
               <a:rPr lang="en-US" smtClean="0"/>
-              <a:t>1/27/13</a:t>
+              <a:t>7/8/2026</a:t>
             </a:fld>
             <a:endParaRPr lang="en-US"/>
           </a:p>
@@ -2370,10 +2368,9 @@
           </a:lstStyle>
           <a:p>
             <a:r>
-              <a:rPr lang="en-US" smtClean="0"/>
+              <a:rPr lang="en-US"/>
               <a:t>Click to edit Master title style</a:t>
             </a:r>
-            <a:endParaRPr lang="en-US"/>
           </a:p>
         </p:txBody>
       </p:sp>
@@ -2497,7 +2494,7 @@
           <a:p>
             <a:pPr lvl="0"/>
             <a:r>
-              <a:rPr lang="en-US" smtClean="0"/>
+              <a:rPr lang="en-US"/>
               <a:t>Click to edit Master text styles</a:t>
             </a:r>
           </a:p>
@@ -2520,7 +2517,7 @@
           <a:p>
             <a:fld id="{5BCAD085-E8A6-8845-BD4E-CB4CCA059FC4}" type="datetimeFigureOut">
               <a:rPr lang="en-US" smtClean="0"/>
-              <a:t>1/27/13</a:t>
+              <a:t>7/8/2026</a:t>
             </a:fld>
             <a:endParaRPr lang="en-US"/>
           </a:p>
@@ -2629,10 +2626,9 @@
           <a:lstStyle/>
           <a:p>
             <a:r>
-              <a:rPr lang="en-US" smtClean="0"/>
+              <a:rPr lang="en-US"/>
               <a:t>Click to edit Master title style</a:t>
             </a:r>
-            <a:endParaRPr lang="en-US"/>
           </a:p>
         </p:txBody>
       </p:sp>
@@ -2663,38 +2659,37 @@
           <a:p>
             <a:pPr lvl="0"/>
             <a:r>
-              <a:rPr lang="en-US" smtClean="0"/>
+              <a:rPr lang="en-US"/>
               <a:t>Click to edit Master text styles</a:t>
             </a:r>
           </a:p>
           <a:p>
             <a:pPr lvl="1"/>
             <a:r>
-              <a:rPr lang="en-US" smtClean="0"/>
+              <a:rPr lang="en-US"/>
               <a:t>Second level</a:t>
             </a:r>
           </a:p>
           <a:p>
             <a:pPr lvl="2"/>
             <a:r>
-              <a:rPr lang="en-US" smtClean="0"/>
+              <a:rPr lang="en-US"/>
               <a:t>Third level</a:t>
             </a:r>
           </a:p>
           <a:p>
             <a:pPr lvl="3"/>
             <a:r>
-              <a:rPr lang="en-US" smtClean="0"/>
+              <a:rPr lang="en-US"/>
               <a:t>Fourth level</a:t>
             </a:r>
           </a:p>
           <a:p>
             <a:pPr lvl="4"/>
             <a:r>
-              <a:rPr lang="en-US" smtClean="0"/>
+              <a:rPr lang="en-US"/>
               <a:t>Fifth level</a:t>
             </a:r>
-            <a:endParaRPr lang="en-US"/>
           </a:p>
         </p:txBody>
       </p:sp>
@@ -2733,7 +2728,7 @@
           <a:p>
             <a:fld id="{5BCAD085-E8A6-8845-BD4E-CB4CCA059FC4}" type="datetimeFigureOut">
               <a:rPr lang="en-US" smtClean="0"/>
-              <a:t>1/27/13</a:t>
+              <a:t>7/8/2026</a:t>
             </a:fld>
             <a:endParaRPr lang="en-US"/>
           </a:p>
@@ -3092,7 +3087,7 @@
 </file>
 
 <file path=ppt/slides/slide1.xml><?xml version="1.0" encoding="utf-8"?>
-<p:sld xmlns:a="http://schemas.openxmlformats.org/drawingml/2006/main" xmlns:p="http://schemas.openxmlformats.org/presentationml/2006/main" xmlns:r="http://schemas.openxmlformats.org/officeDocument/2006/relationships">
+<p:sld xmlns:a="http://schemas.openxmlformats.org/drawingml/2006/main" xmlns:r="http://schemas.openxmlformats.org/officeDocument/2006/relationships" xmlns:p="http://schemas.openxmlformats.org/presentationml/2006/main">
   <p:cSld>
     <p:bg>
       <p:bgPr>
@@ -3108,7 +3103,14 @@
         <p:cNvGrpSpPr/>
         <p:nvPr/>
       </p:nvGrpSpPr>
-      <p:grpSpPr/>
+      <p:grpSpPr>
+        <a:xfrm>
+          <a:off x="0" y="0"/>
+          <a:ext cx="0" cy="0"/>
+          <a:chOff x="0" y="0"/>
+          <a:chExt cx="0" cy="0"/>
+        </a:xfrm>
+      </p:grpSpPr>
       <p:sp>
         <p:nvSpPr>
           <p:cNvPr id="2" name="Rounded Rectangle 1"/>
@@ -3145,7 +3147,7 @@
           </a:fontRef>
         </p:style>
         <p:txBody>
-          <a:bodyPr rtlCol="0" anchor="ctr" wrap="square"/>
+          <a:bodyPr wrap="square" rtlCol="0" anchor="ctr"/>
           <a:lstStyle/>
           <a:p>
             <a:pPr algn="ctr">
@@ -3319,7 +3321,7 @@
 </file>
 
 <file path=ppt/slides/slide10.xml><?xml version="1.0" encoding="utf-8"?>
-<p:sld xmlns:a="http://schemas.openxmlformats.org/drawingml/2006/main" xmlns:p="http://schemas.openxmlformats.org/presentationml/2006/main" xmlns:r="http://schemas.openxmlformats.org/officeDocument/2006/relationships">
+<p:sld xmlns:a="http://schemas.openxmlformats.org/drawingml/2006/main" xmlns:r="http://schemas.openxmlformats.org/officeDocument/2006/relationships" xmlns:p="http://schemas.openxmlformats.org/presentationml/2006/main">
   <p:cSld>
     <p:bg>
       <p:bgPr>
@@ -3335,7 +3337,14 @@
         <p:cNvGrpSpPr/>
         <p:nvPr/>
       </p:nvGrpSpPr>
-      <p:grpSpPr/>
+      <p:grpSpPr>
+        <a:xfrm>
+          <a:off x="0" y="0"/>
+          <a:ext cx="0" cy="0"/>
+          <a:chOff x="0" y="0"/>
+          <a:chExt cx="0" cy="0"/>
+        </a:xfrm>
+      </p:grpSpPr>
       <p:sp>
         <p:nvSpPr>
           <p:cNvPr id="2" name="TextBox 1"/>
@@ -3412,6 +3421,7 @@
           <a:lstStyle/>
           <a:p>
             <a:pPr algn="ctr"/>
+            <a:endParaRPr/>
           </a:p>
         </p:txBody>
       </p:sp>
@@ -3516,6 +3526,7 @@
                 <a:latin typeface="Segoe UI"/>
               </a:defRPr>
             </a:pPr>
+            <a:endParaRPr/>
           </a:p>
           <a:p>
             <a:pPr>
@@ -3545,6 +3556,7 @@
                 <a:latin typeface="Segoe UI"/>
               </a:defRPr>
             </a:pPr>
+            <a:endParaRPr/>
           </a:p>
           <a:p>
             <a:pPr>
@@ -3638,6 +3650,7 @@
                 <a:latin typeface="Segoe UI"/>
               </a:defRPr>
             </a:pPr>
+            <a:endParaRPr/>
           </a:p>
           <a:p>
             <a:pPr>
@@ -3667,6 +3680,7 @@
                 <a:latin typeface="Segoe UI"/>
               </a:defRPr>
             </a:pPr>
+            <a:endParaRPr/>
           </a:p>
           <a:p>
             <a:pPr>
@@ -3726,6 +3740,7 @@
           <a:lstStyle/>
           <a:p>
             <a:pPr algn="ctr"/>
+            <a:endParaRPr/>
           </a:p>
         </p:txBody>
       </p:sp>
@@ -3846,6 +3861,7 @@
                 <a:latin typeface="Segoe UI"/>
               </a:defRPr>
             </a:pPr>
+            <a:endParaRPr/>
           </a:p>
           <a:p>
             <a:pPr>
@@ -3923,6 +3939,7 @@
                 <a:latin typeface="Segoe UI"/>
               </a:defRPr>
             </a:pPr>
+            <a:endParaRPr/>
           </a:p>
           <a:p>
             <a:pPr>
@@ -4000,6 +4017,7 @@
                 <a:latin typeface="Segoe UI"/>
               </a:defRPr>
             </a:pPr>
+            <a:endParaRPr/>
           </a:p>
           <a:p>
             <a:pPr>
@@ -4076,7 +4094,7 @@
 </file>
 
 <file path=ppt/slides/slide11.xml><?xml version="1.0" encoding="utf-8"?>
-<p:sld xmlns:a="http://schemas.openxmlformats.org/drawingml/2006/main" xmlns:p="http://schemas.openxmlformats.org/presentationml/2006/main" xmlns:r="http://schemas.openxmlformats.org/officeDocument/2006/relationships">
+<p:sld xmlns:a="http://schemas.openxmlformats.org/drawingml/2006/main" xmlns:r="http://schemas.openxmlformats.org/officeDocument/2006/relationships" xmlns:p="http://schemas.openxmlformats.org/presentationml/2006/main">
   <p:cSld>
     <p:bg>
       <p:bgPr>
@@ -4092,7 +4110,14 @@
         <p:cNvGrpSpPr/>
         <p:nvPr/>
       </p:nvGrpSpPr>
-      <p:grpSpPr/>
+      <p:grpSpPr>
+        <a:xfrm>
+          <a:off x="0" y="0"/>
+          <a:ext cx="0" cy="0"/>
+          <a:chOff x="0" y="0"/>
+          <a:chExt cx="0" cy="0"/>
+        </a:xfrm>
+      </p:grpSpPr>
       <p:sp>
         <p:nvSpPr>
           <p:cNvPr id="2" name="TextBox 1"/>
@@ -4165,7 +4190,7 @@
           </a:fontRef>
         </p:style>
         <p:txBody>
-          <a:bodyPr rtlCol="0" anchor="ctr" wrap="square"/>
+          <a:bodyPr wrap="square" rtlCol="0" anchor="ctr"/>
           <a:lstStyle/>
           <a:p>
             <a:pPr algn="ctr">
@@ -4294,7 +4319,7 @@
           </a:fontRef>
         </p:style>
         <p:txBody>
-          <a:bodyPr rtlCol="0" anchor="ctr" wrap="square"/>
+          <a:bodyPr wrap="square" rtlCol="0" anchor="ctr"/>
           <a:lstStyle/>
           <a:p>
             <a:pPr algn="ctr">
@@ -4423,7 +4448,7 @@
           </a:fontRef>
         </p:style>
         <p:txBody>
-          <a:bodyPr rtlCol="0" anchor="ctr" wrap="square"/>
+          <a:bodyPr wrap="square" rtlCol="0" anchor="ctr"/>
           <a:lstStyle/>
           <a:p>
             <a:pPr algn="ctr">
@@ -4552,7 +4577,7 @@
           </a:fontRef>
         </p:style>
         <p:txBody>
-          <a:bodyPr rtlCol="0" anchor="ctr" wrap="square"/>
+          <a:bodyPr wrap="square" rtlCol="0" anchor="ctr"/>
           <a:lstStyle/>
           <a:p>
             <a:pPr algn="ctr">
@@ -4653,7 +4678,7 @@
         </p:nvSpPr>
         <p:spPr>
           <a:xfrm>
-            <a:off x="731520" y="5760720"/>
+            <a:off x="6797585" y="1531620"/>
             <a:ext cx="5486400" cy="365760"/>
           </a:xfrm>
           <a:prstGeom prst="rect">
@@ -4676,6 +4701,7 @@
               </a:defRPr>
             </a:pPr>
             <a:r>
+              <a:rPr dirty="0"/>
               <a:t>What we DON'T require:</a:t>
             </a:r>
           </a:p>
@@ -4689,8 +4715,8 @@
         </p:nvSpPr>
         <p:spPr>
           <a:xfrm>
-            <a:off x="731520" y="6035040"/>
-            <a:ext cx="7315200" cy="914400"/>
+            <a:off x="6797585" y="2057400"/>
+            <a:ext cx="4557600" cy="923330"/>
           </a:xfrm>
           <a:prstGeom prst="rect">
             <a:avLst/>
@@ -4715,6 +4741,7 @@
               </a:defRPr>
             </a:pPr>
             <a:r>
+              <a:rPr dirty="0"/>
               <a:t>  ✖  No hardware installation</a:t>
             </a:r>
           </a:p>
@@ -4731,6 +4758,7 @@
               </a:defRPr>
             </a:pPr>
             <a:r>
+              <a:rPr dirty="0"/>
               <a:t>  ✖  No IT project (cloud-based, nothing to install)</a:t>
             </a:r>
           </a:p>
@@ -4747,6 +4775,7 @@
               </a:defRPr>
             </a:pPr>
             <a:r>
+              <a:rPr dirty="0"/>
               <a:t>  ✖  No replacing your existing systems (we sit on top)</a:t>
             </a:r>
           </a:p>
@@ -4763,6 +4792,7 @@
               </a:defRPr>
             </a:pPr>
             <a:r>
+              <a:rPr dirty="0"/>
               <a:t>  ✖  No 6-month implementation consultants</a:t>
             </a:r>
           </a:p>
@@ -4777,7 +4807,7 @@
 </file>
 
 <file path=ppt/slides/slide12.xml><?xml version="1.0" encoding="utf-8"?>
-<p:sld xmlns:a="http://schemas.openxmlformats.org/drawingml/2006/main" xmlns:p="http://schemas.openxmlformats.org/presentationml/2006/main" xmlns:r="http://schemas.openxmlformats.org/officeDocument/2006/relationships">
+<p:sld xmlns:a="http://schemas.openxmlformats.org/drawingml/2006/main" xmlns:r="http://schemas.openxmlformats.org/officeDocument/2006/relationships" xmlns:p="http://schemas.openxmlformats.org/presentationml/2006/main">
   <p:cSld>
     <p:bg>
       <p:bgPr>
@@ -4793,7 +4823,14 @@
         <p:cNvGrpSpPr/>
         <p:nvPr/>
       </p:nvGrpSpPr>
-      <p:grpSpPr/>
+      <p:grpSpPr>
+        <a:xfrm>
+          <a:off x="0" y="0"/>
+          <a:ext cx="0" cy="0"/>
+          <a:chOff x="0" y="0"/>
+          <a:chExt cx="0" cy="0"/>
+        </a:xfrm>
+      </p:grpSpPr>
       <p:sp>
         <p:nvSpPr>
           <p:cNvPr id="2" name="TextBox 1"/>
@@ -4906,6 +4943,7 @@
           <a:lstStyle/>
           <a:p>
             <a:pPr algn="ctr"/>
+            <a:endParaRPr/>
           </a:p>
         </p:txBody>
       </p:sp>
@@ -5061,6 +5099,7 @@
           <a:lstStyle/>
           <a:p>
             <a:pPr algn="ctr"/>
+            <a:endParaRPr/>
           </a:p>
         </p:txBody>
       </p:sp>
@@ -5216,6 +5255,7 @@
           <a:lstStyle/>
           <a:p>
             <a:pPr algn="ctr"/>
+            <a:endParaRPr/>
           </a:p>
         </p:txBody>
       </p:sp>
@@ -5376,7 +5416,7 @@
 </file>
 
 <file path=ppt/slides/slide13.xml><?xml version="1.0" encoding="utf-8"?>
-<p:sld xmlns:a="http://schemas.openxmlformats.org/drawingml/2006/main" xmlns:p="http://schemas.openxmlformats.org/presentationml/2006/main" xmlns:r="http://schemas.openxmlformats.org/officeDocument/2006/relationships">
+<p:sld xmlns:a="http://schemas.openxmlformats.org/drawingml/2006/main" xmlns:r="http://schemas.openxmlformats.org/officeDocument/2006/relationships" xmlns:p="http://schemas.openxmlformats.org/presentationml/2006/main">
   <p:cSld>
     <p:bg>
       <p:bgPr>
@@ -5392,7 +5432,14 @@
         <p:cNvGrpSpPr/>
         <p:nvPr/>
       </p:nvGrpSpPr>
-      <p:grpSpPr/>
+      <p:grpSpPr>
+        <a:xfrm>
+          <a:off x="0" y="0"/>
+          <a:ext cx="0" cy="0"/>
+          <a:chOff x="0" y="0"/>
+          <a:chExt cx="0" cy="0"/>
+        </a:xfrm>
+      </p:grpSpPr>
       <p:sp>
         <p:nvSpPr>
           <p:cNvPr id="2" name="TextBox 1"/>
@@ -5478,6 +5525,7 @@
                 <a:latin typeface="Segoe UI"/>
               </a:defRPr>
             </a:pPr>
+            <a:endParaRPr/>
           </a:p>
           <a:p>
             <a:pPr>
@@ -5539,6 +5587,7 @@
                 <a:latin typeface="Segoe UI"/>
               </a:defRPr>
             </a:pPr>
+            <a:endParaRPr/>
           </a:p>
           <a:p>
             <a:pPr>
@@ -5568,6 +5617,7 @@
                 <a:latin typeface="Segoe UI"/>
               </a:defRPr>
             </a:pPr>
+            <a:endParaRPr/>
           </a:p>
           <a:p>
             <a:pPr>
@@ -5645,6 +5695,7 @@
                 <a:latin typeface="Segoe UI"/>
               </a:defRPr>
             </a:pPr>
+            <a:endParaRPr/>
           </a:p>
           <a:p>
             <a:pPr>
@@ -5737,7 +5788,7 @@
 </file>
 
 <file path=ppt/slides/slide14.xml><?xml version="1.0" encoding="utf-8"?>
-<p:sld xmlns:a="http://schemas.openxmlformats.org/drawingml/2006/main" xmlns:p="http://schemas.openxmlformats.org/presentationml/2006/main" xmlns:r="http://schemas.openxmlformats.org/officeDocument/2006/relationships">
+<p:sld xmlns:a="http://schemas.openxmlformats.org/drawingml/2006/main" xmlns:r="http://schemas.openxmlformats.org/officeDocument/2006/relationships" xmlns:p="http://schemas.openxmlformats.org/presentationml/2006/main">
   <p:cSld>
     <p:bg>
       <p:bgPr>
@@ -5753,7 +5804,14 @@
         <p:cNvGrpSpPr/>
         <p:nvPr/>
       </p:nvGrpSpPr>
-      <p:grpSpPr/>
+      <p:grpSpPr>
+        <a:xfrm>
+          <a:off x="0" y="0"/>
+          <a:ext cx="0" cy="0"/>
+          <a:chOff x="0" y="0"/>
+          <a:chExt cx="0" cy="0"/>
+        </a:xfrm>
+      </p:grpSpPr>
       <p:sp>
         <p:nvSpPr>
           <p:cNvPr id="2" name="Rounded Rectangle 1"/>
@@ -5790,7 +5848,7 @@
           </a:fontRef>
         </p:style>
         <p:txBody>
-          <a:bodyPr rtlCol="0" anchor="ctr" wrap="square"/>
+          <a:bodyPr wrap="square" rtlCol="0" anchor="ctr"/>
           <a:lstStyle/>
           <a:p>
             <a:pPr algn="ctr">
@@ -5924,6 +5982,7 @@
                 <a:latin typeface="Segoe UI"/>
               </a:defRPr>
             </a:pPr>
+            <a:endParaRPr/>
           </a:p>
           <a:p>
             <a:pPr>
@@ -5988,7 +6047,7 @@
 </file>
 
 <file path=ppt/slides/slide2.xml><?xml version="1.0" encoding="utf-8"?>
-<p:sld xmlns:a="http://schemas.openxmlformats.org/drawingml/2006/main" xmlns:p="http://schemas.openxmlformats.org/presentationml/2006/main" xmlns:r="http://schemas.openxmlformats.org/officeDocument/2006/relationships">
+<p:sld xmlns:a="http://schemas.openxmlformats.org/drawingml/2006/main" xmlns:r="http://schemas.openxmlformats.org/officeDocument/2006/relationships" xmlns:p="http://schemas.openxmlformats.org/presentationml/2006/main">
   <p:cSld>
     <p:bg>
       <p:bgPr>
@@ -6004,7 +6063,14 @@
         <p:cNvGrpSpPr/>
         <p:nvPr/>
       </p:nvGrpSpPr>
-      <p:grpSpPr/>
+      <p:grpSpPr>
+        <a:xfrm>
+          <a:off x="0" y="0"/>
+          <a:ext cx="0" cy="0"/>
+          <a:chOff x="0" y="0"/>
+          <a:chExt cx="0" cy="0"/>
+        </a:xfrm>
+      </p:grpSpPr>
       <p:sp>
         <p:nvSpPr>
           <p:cNvPr id="2" name="TextBox 1"/>
@@ -6425,6 +6491,7 @@
               </a:defRPr>
             </a:pPr>
             <a:r>
+              <a:rPr dirty="0"/>
               <a:t>What keeps hospital leaders up at night:</a:t>
             </a:r>
           </a:p>
@@ -6440,6 +6507,7 @@
                 <a:latin typeface="Segoe UI"/>
               </a:defRPr>
             </a:pPr>
+            <a:endParaRPr dirty="0"/>
           </a:p>
           <a:p>
             <a:pPr>
@@ -6454,14 +6522,17 @@
               </a:defRPr>
             </a:pPr>
             <a:r>
+              <a:rPr dirty="0"/>
               <a:t>  Program Directors: "Did any resident exceed 80 hours this week?"</a:t>
             </a:r>
           </a:p>
           <a:p>
-            <a:pPr>
+            <a:pPr marL="285750" indent="-285750">
               <a:spcAft>
                 <a:spcPts val="624"/>
               </a:spcAft>
+              <a:buFont typeface="Arial" panose="020B0604020202020204" pitchFamily="34" charset="0"/>
+              <a:buChar char="•"/>
               <a:defRPr sz="1300" b="0">
                 <a:solidFill>
                   <a:srgbClr val="9CA3AF"/>
@@ -6470,7 +6541,8 @@
               </a:defRPr>
             </a:pPr>
             <a:r>
-              <a:t>  — ACGME violations can shut down your residency program</a:t>
+              <a:rPr dirty="0"/>
+              <a:t>  ACGME violations can shut down your residency program</a:t>
             </a:r>
           </a:p>
           <a:p>
@@ -6485,6 +6557,7 @@
                 <a:latin typeface="Segoe UI"/>
               </a:defRPr>
             </a:pPr>
+            <a:endParaRPr dirty="0"/>
           </a:p>
           <a:p>
             <a:pPr>
@@ -6499,14 +6572,17 @@
               </a:defRPr>
             </a:pPr>
             <a:r>
+              <a:rPr dirty="0"/>
               <a:t>  CNOs: "Are we meeting nurse-to-patient ratios on every unit?"</a:t>
             </a:r>
           </a:p>
           <a:p>
-            <a:pPr>
+            <a:pPr marL="285750" indent="-285750">
               <a:spcAft>
                 <a:spcPts val="624"/>
               </a:spcAft>
+              <a:buFont typeface="Arial" panose="020B0604020202020204" pitchFamily="34" charset="0"/>
+              <a:buChar char="•"/>
               <a:defRPr sz="1300" b="0">
                 <a:solidFill>
                   <a:srgbClr val="9CA3AF"/>
@@ -6515,7 +6591,8 @@
               </a:defRPr>
             </a:pPr>
             <a:r>
-              <a:t>  — CMS citations, Joint Commission findings, patient safety events</a:t>
+              <a:rPr dirty="0"/>
+              <a:t>CMS citations, Joint Commission findings, patient safety events</a:t>
             </a:r>
           </a:p>
           <a:p>
@@ -6530,6 +6607,7 @@
                 <a:latin typeface="Segoe UI"/>
               </a:defRPr>
             </a:pPr>
+            <a:endParaRPr dirty="0"/>
           </a:p>
           <a:p>
             <a:pPr>
@@ -6544,14 +6622,25 @@
               </a:defRPr>
             </a:pPr>
             <a:r>
-              <a:t>  CMOs: "Is our call schedule fair — or is it a burnout machine?"</a:t>
-            </a:r>
-          </a:p>
-          <a:p>
-            <a:pPr>
+              <a:rPr dirty="0"/>
+              <a:t>  CMOs: "Is our call schedule fair </a:t>
+            </a:r>
+            <a:r>
+              <a:rPr lang="en-US" dirty="0"/>
+              <a:t>-</a:t>
+            </a:r>
+            <a:r>
+              <a:rPr dirty="0"/>
+              <a:t> or is it a burnout machine?"</a:t>
+            </a:r>
+          </a:p>
+          <a:p>
+            <a:pPr marL="285750" indent="-285750">
               <a:spcAft>
                 <a:spcPts val="624"/>
               </a:spcAft>
+              <a:buFont typeface="Arial" panose="020B0604020202020204" pitchFamily="34" charset="0"/>
+              <a:buChar char="•"/>
               <a:defRPr sz="1300" b="0">
                 <a:solidFill>
                   <a:srgbClr val="9CA3AF"/>
@@ -6560,7 +6649,8 @@
               </a:defRPr>
             </a:pPr>
             <a:r>
-              <a:t>  — Unfair schedules drive 43% of nursing turnover ($56K per nurse lost)</a:t>
+              <a:rPr dirty="0"/>
+              <a:t>  Unfair schedules drive 43% of nursing turnover ($56K per nurse lost)</a:t>
             </a:r>
           </a:p>
           <a:p>
@@ -6575,6 +6665,7 @@
                 <a:latin typeface="Segoe UI"/>
               </a:defRPr>
             </a:pPr>
+            <a:endParaRPr dirty="0"/>
           </a:p>
           <a:p>
             <a:pPr>
@@ -6589,14 +6680,17 @@
               </a:defRPr>
             </a:pPr>
             <a:r>
+              <a:rPr dirty="0"/>
               <a:t>  HR/Compliance: "Can we prove we checked before we published?"</a:t>
             </a:r>
           </a:p>
           <a:p>
-            <a:pPr>
+            <a:pPr marL="285750" indent="-285750">
               <a:spcAft>
                 <a:spcPts val="624"/>
               </a:spcAft>
+              <a:buFont typeface="Arial" panose="020B0604020202020204" pitchFamily="34" charset="0"/>
+              <a:buChar char="•"/>
               <a:defRPr sz="1300" b="0">
                 <a:solidFill>
                   <a:srgbClr val="9CA3AF"/>
@@ -6605,7 +6699,16 @@
               </a:defRPr>
             </a:pPr>
             <a:r>
-              <a:t>  — DOL investigations, class-actions, no audit trail of compliance checks</a:t>
+              <a:rPr dirty="0"/>
+              <a:t> </a:t>
+            </a:r>
+            <a:r>
+              <a:rPr lang="en-US" dirty="0"/>
+              <a:t> </a:t>
+            </a:r>
+            <a:r>
+              <a:rPr dirty="0"/>
+              <a:t>DOL investigations, class-actions, no audit trail of compliance checks</a:t>
             </a:r>
           </a:p>
         </p:txBody>
@@ -6619,7 +6722,7 @@
 </file>
 
 <file path=ppt/slides/slide3.xml><?xml version="1.0" encoding="utf-8"?>
-<p:sld xmlns:a="http://schemas.openxmlformats.org/drawingml/2006/main" xmlns:p="http://schemas.openxmlformats.org/presentationml/2006/main" xmlns:r="http://schemas.openxmlformats.org/officeDocument/2006/relationships">
+<p:sld xmlns:a="http://schemas.openxmlformats.org/drawingml/2006/main" xmlns:r="http://schemas.openxmlformats.org/officeDocument/2006/relationships" xmlns:p="http://schemas.openxmlformats.org/presentationml/2006/main">
   <p:cSld>
     <p:bg>
       <p:bgPr>
@@ -6635,7 +6738,14 @@
         <p:cNvGrpSpPr/>
         <p:nvPr/>
       </p:nvGrpSpPr>
-      <p:grpSpPr/>
+      <p:grpSpPr>
+        <a:xfrm>
+          <a:off x="0" y="0"/>
+          <a:ext cx="0" cy="0"/>
+          <a:chOff x="0" y="0"/>
+          <a:chExt cx="0" cy="0"/>
+        </a:xfrm>
+      </p:grpSpPr>
       <p:sp>
         <p:nvSpPr>
           <p:cNvPr id="2" name="TextBox 1"/>
@@ -6712,6 +6822,7 @@
           <a:lstStyle/>
           <a:p>
             <a:pPr algn="ctr"/>
+            <a:endParaRPr/>
           </a:p>
         </p:txBody>
       </p:sp>
@@ -6755,6 +6866,7 @@
           <a:lstStyle/>
           <a:p>
             <a:pPr algn="ctr"/>
+            <a:endParaRPr/>
           </a:p>
         </p:txBody>
       </p:sp>
@@ -6906,6 +7018,7 @@
           <a:lstStyle/>
           <a:p>
             <a:pPr algn="ctr"/>
+            <a:endParaRPr/>
           </a:p>
         </p:txBody>
       </p:sp>
@@ -6949,6 +7062,7 @@
           <a:lstStyle/>
           <a:p>
             <a:pPr algn="ctr"/>
+            <a:endParaRPr/>
           </a:p>
         </p:txBody>
       </p:sp>
@@ -7100,6 +7214,7 @@
           <a:lstStyle/>
           <a:p>
             <a:pPr algn="ctr"/>
+            <a:endParaRPr/>
           </a:p>
         </p:txBody>
       </p:sp>
@@ -7143,6 +7258,7 @@
           <a:lstStyle/>
           <a:p>
             <a:pPr algn="ctr"/>
+            <a:endParaRPr/>
           </a:p>
         </p:txBody>
       </p:sp>
@@ -7263,7 +7379,7 @@
 </file>
 
 <file path=ppt/slides/slide4.xml><?xml version="1.0" encoding="utf-8"?>
-<p:sld xmlns:a="http://schemas.openxmlformats.org/drawingml/2006/main" xmlns:p="http://schemas.openxmlformats.org/presentationml/2006/main" xmlns:r="http://schemas.openxmlformats.org/officeDocument/2006/relationships">
+<p:sld xmlns:a="http://schemas.openxmlformats.org/drawingml/2006/main" xmlns:r="http://schemas.openxmlformats.org/officeDocument/2006/relationships" xmlns:p="http://schemas.openxmlformats.org/presentationml/2006/main">
   <p:cSld>
     <p:bg>
       <p:bgPr>
@@ -7279,7 +7395,14 @@
         <p:cNvGrpSpPr/>
         <p:nvPr/>
       </p:nvGrpSpPr>
-      <p:grpSpPr/>
+      <p:grpSpPr>
+        <a:xfrm>
+          <a:off x="0" y="0"/>
+          <a:ext cx="0" cy="0"/>
+          <a:chOff x="0" y="0"/>
+          <a:chExt cx="0" cy="0"/>
+        </a:xfrm>
+      </p:grpSpPr>
       <p:sp>
         <p:nvSpPr>
           <p:cNvPr id="2" name="TextBox 1"/>
@@ -7356,6 +7479,7 @@
           <a:lstStyle/>
           <a:p>
             <a:pPr algn="ctr"/>
+            <a:endParaRPr/>
           </a:p>
         </p:txBody>
       </p:sp>
@@ -7404,7 +7528,7 @@
         <p:spPr>
           <a:xfrm>
             <a:off x="731520" y="2011680"/>
-            <a:ext cx="3291840" cy="4114800"/>
+            <a:ext cx="3291840" cy="2026196"/>
           </a:xfrm>
           <a:prstGeom prst="rect">
             <a:avLst/>
@@ -7429,6 +7553,7 @@
               </a:defRPr>
             </a:pPr>
             <a:r>
+              <a:rPr dirty="0"/>
               <a:t>• See ACGME compliance status across ALL residents at a glance</a:t>
             </a:r>
           </a:p>
@@ -7445,7 +7570,16 @@
               </a:defRPr>
             </a:pPr>
             <a:r>
-              <a:t>• 80h/week 4-week rolling average — tracked automatically</a:t>
+              <a:rPr dirty="0"/>
+              <a:t>• 80h/week 4-week rolling average </a:t>
+            </a:r>
+            <a:r>
+              <a:rPr lang="en-US" dirty="0"/>
+              <a:t>-</a:t>
+            </a:r>
+            <a:r>
+              <a:rPr dirty="0"/>
+              <a:t> tracked automatically</a:t>
             </a:r>
           </a:p>
           <a:p>
@@ -7461,6 +7595,7 @@
               </a:defRPr>
             </a:pPr>
             <a:r>
+              <a:rPr dirty="0"/>
               <a:t>• Swap requests pre-checked: "Will this swap violate 24+4?"</a:t>
             </a:r>
           </a:p>
@@ -7477,6 +7612,7 @@
               </a:defRPr>
             </a:pPr>
             <a:r>
+              <a:rPr dirty="0"/>
               <a:t>• Generate fair year schedule (AI distributes nights/weekends equally)</a:t>
             </a:r>
           </a:p>
@@ -7493,6 +7629,7 @@
               </a:defRPr>
             </a:pPr>
             <a:r>
+              <a:rPr dirty="0"/>
               <a:t>• One-click ACGME report for site visits</a:t>
             </a:r>
           </a:p>
@@ -7538,6 +7675,7 @@
           <a:lstStyle/>
           <a:p>
             <a:pPr algn="ctr"/>
+            <a:endParaRPr/>
           </a:p>
         </p:txBody>
       </p:sp>
@@ -7720,6 +7858,7 @@
           <a:lstStyle/>
           <a:p>
             <a:pPr algn="ctr"/>
+            <a:endParaRPr/>
           </a:p>
         </p:txBody>
       </p:sp>
@@ -7871,7 +8010,7 @@
 </file>
 
 <file path=ppt/slides/slide5.xml><?xml version="1.0" encoding="utf-8"?>
-<p:sld xmlns:a="http://schemas.openxmlformats.org/drawingml/2006/main" xmlns:p="http://schemas.openxmlformats.org/presentationml/2006/main" xmlns:r="http://schemas.openxmlformats.org/officeDocument/2006/relationships">
+<p:sld xmlns:a="http://schemas.openxmlformats.org/drawingml/2006/main" xmlns:r="http://schemas.openxmlformats.org/officeDocument/2006/relationships" xmlns:p="http://schemas.openxmlformats.org/presentationml/2006/main">
   <p:cSld>
     <p:bg>
       <p:bgPr>
@@ -7887,7 +8026,14 @@
         <p:cNvGrpSpPr/>
         <p:nvPr/>
       </p:nvGrpSpPr>
-      <p:grpSpPr/>
+      <p:grpSpPr>
+        <a:xfrm>
+          <a:off x="0" y="0"/>
+          <a:ext cx="0" cy="0"/>
+          <a:chOff x="0" y="0"/>
+          <a:chExt cx="0" cy="0"/>
+        </a:xfrm>
+      </p:grpSpPr>
       <p:sp>
         <p:nvSpPr>
           <p:cNvPr id="2" name="TextBox 1"/>
@@ -9085,7 +9231,7 @@
 </file>
 
 <file path=ppt/slides/slide6.xml><?xml version="1.0" encoding="utf-8"?>
-<p:sld xmlns:a="http://schemas.openxmlformats.org/drawingml/2006/main" xmlns:p="http://schemas.openxmlformats.org/presentationml/2006/main" xmlns:r="http://schemas.openxmlformats.org/officeDocument/2006/relationships">
+<p:sld xmlns:a="http://schemas.openxmlformats.org/drawingml/2006/main" xmlns:r="http://schemas.openxmlformats.org/officeDocument/2006/relationships" xmlns:p="http://schemas.openxmlformats.org/presentationml/2006/main">
   <p:cSld>
     <p:bg>
       <p:bgPr>
@@ -9101,7 +9247,14 @@
         <p:cNvGrpSpPr/>
         <p:nvPr/>
       </p:nvGrpSpPr>
-      <p:grpSpPr/>
+      <p:grpSpPr>
+        <a:xfrm>
+          <a:off x="0" y="0"/>
+          <a:ext cx="0" cy="0"/>
+          <a:chOff x="0" y="0"/>
+          <a:chExt cx="0" cy="0"/>
+        </a:xfrm>
+      </p:grpSpPr>
       <p:sp>
         <p:nvSpPr>
           <p:cNvPr id="2" name="TextBox 1"/>
@@ -9214,6 +9367,7 @@
           <a:lstStyle/>
           <a:p>
             <a:pPr algn="ctr"/>
+            <a:endParaRPr/>
           </a:p>
         </p:txBody>
       </p:sp>
@@ -9266,6 +9420,7 @@
                 <a:latin typeface="Segoe UI"/>
               </a:defRPr>
             </a:pPr>
+            <a:endParaRPr/>
           </a:p>
           <a:p>
             <a:pPr>
@@ -9327,6 +9482,7 @@
                 <a:latin typeface="Segoe UI"/>
               </a:defRPr>
             </a:pPr>
+            <a:endParaRPr/>
           </a:p>
           <a:p>
             <a:pPr>
@@ -9372,6 +9528,7 @@
                 <a:latin typeface="Segoe UI"/>
               </a:defRPr>
             </a:pPr>
+            <a:endParaRPr/>
           </a:p>
           <a:p>
             <a:pPr>
@@ -9401,6 +9558,7 @@
                 <a:latin typeface="Segoe UI"/>
               </a:defRPr>
             </a:pPr>
+            <a:endParaRPr/>
           </a:p>
           <a:p>
             <a:pPr>
@@ -9549,6 +9707,7 @@
                 <a:latin typeface="Segoe UI"/>
               </a:defRPr>
             </a:pPr>
+            <a:endParaRPr/>
           </a:p>
           <a:p>
             <a:pPr>
@@ -9658,6 +9817,7 @@
                 <a:latin typeface="Segoe UI"/>
               </a:defRPr>
             </a:pPr>
+            <a:endParaRPr/>
           </a:p>
           <a:p>
             <a:pPr>
@@ -9703,6 +9863,7 @@
                 <a:latin typeface="Segoe UI"/>
               </a:defRPr>
             </a:pPr>
+            <a:endParaRPr/>
           </a:p>
           <a:p>
             <a:pPr>
@@ -9763,7 +9924,7 @@
 </file>
 
 <file path=ppt/slides/slide7.xml><?xml version="1.0" encoding="utf-8"?>
-<p:sld xmlns:a="http://schemas.openxmlformats.org/drawingml/2006/main" xmlns:p="http://schemas.openxmlformats.org/presentationml/2006/main" xmlns:r="http://schemas.openxmlformats.org/officeDocument/2006/relationships">
+<p:sld xmlns:a="http://schemas.openxmlformats.org/drawingml/2006/main" xmlns:r="http://schemas.openxmlformats.org/officeDocument/2006/relationships" xmlns:p="http://schemas.openxmlformats.org/presentationml/2006/main">
   <p:cSld>
     <p:bg>
       <p:bgPr>
@@ -9779,7 +9940,14 @@
         <p:cNvGrpSpPr/>
         <p:nvPr/>
       </p:nvGrpSpPr>
-      <p:grpSpPr/>
+      <p:grpSpPr>
+        <a:xfrm>
+          <a:off x="0" y="0"/>
+          <a:ext cx="0" cy="0"/>
+          <a:chOff x="0" y="0"/>
+          <a:chExt cx="0" cy="0"/>
+        </a:xfrm>
+      </p:grpSpPr>
       <p:sp>
         <p:nvSpPr>
           <p:cNvPr id="2" name="TextBox 1"/>
@@ -9856,6 +10024,7 @@
           <a:lstStyle/>
           <a:p>
             <a:pPr algn="ctr"/>
+            <a:endParaRPr/>
           </a:p>
         </p:txBody>
       </p:sp>
@@ -9976,6 +10145,7 @@
                 <a:latin typeface="Segoe UI"/>
               </a:defRPr>
             </a:pPr>
+            <a:endParaRPr/>
           </a:p>
           <a:p>
             <a:pPr>
@@ -10005,6 +10175,7 @@
                 <a:latin typeface="Segoe UI"/>
               </a:defRPr>
             </a:pPr>
+            <a:endParaRPr/>
           </a:p>
           <a:p>
             <a:pPr>
@@ -10082,6 +10253,7 @@
                 <a:latin typeface="Segoe UI"/>
               </a:defRPr>
             </a:pPr>
+            <a:endParaRPr/>
           </a:p>
           <a:p>
             <a:pPr>
@@ -10205,6 +10377,7 @@
           <a:lstStyle/>
           <a:p>
             <a:pPr algn="ctr"/>
+            <a:endParaRPr/>
           </a:p>
         </p:txBody>
       </p:sp>
@@ -10293,6 +10466,7 @@
                 <a:latin typeface="Segoe UI"/>
               </a:defRPr>
             </a:pPr>
+            <a:endParaRPr/>
           </a:p>
           <a:p>
             <a:pPr>
@@ -10386,6 +10560,7 @@
                 <a:latin typeface="Segoe UI"/>
               </a:defRPr>
             </a:pPr>
+            <a:endParaRPr/>
           </a:p>
           <a:p>
             <a:pPr>
@@ -10495,6 +10670,7 @@
                 <a:latin typeface="Segoe UI"/>
               </a:defRPr>
             </a:pPr>
+            <a:endParaRPr/>
           </a:p>
           <a:p>
             <a:pPr>
@@ -10539,7 +10715,7 @@
 </file>
 
 <file path=ppt/slides/slide8.xml><?xml version="1.0" encoding="utf-8"?>
-<p:sld xmlns:a="http://schemas.openxmlformats.org/drawingml/2006/main" xmlns:p="http://schemas.openxmlformats.org/presentationml/2006/main" xmlns:r="http://schemas.openxmlformats.org/officeDocument/2006/relationships">
+<p:sld xmlns:a="http://schemas.openxmlformats.org/drawingml/2006/main" xmlns:r="http://schemas.openxmlformats.org/officeDocument/2006/relationships" xmlns:p="http://schemas.openxmlformats.org/presentationml/2006/main">
   <p:cSld>
     <p:bg>
       <p:bgPr>
@@ -10555,7 +10731,14 @@
         <p:cNvGrpSpPr/>
         <p:nvPr/>
       </p:nvGrpSpPr>
-      <p:grpSpPr/>
+      <p:grpSpPr>
+        <a:xfrm>
+          <a:off x="0" y="0"/>
+          <a:ext cx="0" cy="0"/>
+          <a:chOff x="0" y="0"/>
+          <a:chExt cx="0" cy="0"/>
+        </a:xfrm>
+      </p:grpSpPr>
       <p:sp>
         <p:nvSpPr>
           <p:cNvPr id="2" name="TextBox 1"/>
@@ -10668,6 +10851,7 @@
           <a:lstStyle/>
           <a:p>
             <a:pPr algn="ctr"/>
+            <a:endParaRPr/>
           </a:p>
         </p:txBody>
       </p:sp>
@@ -10783,6 +10967,7 @@
           <a:lstStyle/>
           <a:p>
             <a:pPr algn="ctr"/>
+            <a:endParaRPr/>
           </a:p>
         </p:txBody>
       </p:sp>
@@ -10898,6 +11083,7 @@
           <a:lstStyle/>
           <a:p>
             <a:pPr algn="ctr"/>
+            <a:endParaRPr/>
           </a:p>
         </p:txBody>
       </p:sp>
@@ -11013,6 +11199,7 @@
           <a:lstStyle/>
           <a:p>
             <a:pPr algn="ctr"/>
+            <a:endParaRPr/>
           </a:p>
         </p:txBody>
       </p:sp>
@@ -11128,6 +11315,7 @@
           <a:lstStyle/>
           <a:p>
             <a:pPr algn="ctr"/>
+            <a:endParaRPr/>
           </a:p>
         </p:txBody>
       </p:sp>
@@ -11243,6 +11431,7 @@
           <a:lstStyle/>
           <a:p>
             <a:pPr algn="ctr"/>
+            <a:endParaRPr/>
           </a:p>
         </p:txBody>
       </p:sp>
@@ -11363,7 +11552,7 @@
 </file>
 
 <file path=ppt/slides/slide9.xml><?xml version="1.0" encoding="utf-8"?>
-<p:sld xmlns:a="http://schemas.openxmlformats.org/drawingml/2006/main" xmlns:p="http://schemas.openxmlformats.org/presentationml/2006/main" xmlns:r="http://schemas.openxmlformats.org/officeDocument/2006/relationships">
+<p:sld xmlns:a="http://schemas.openxmlformats.org/drawingml/2006/main" xmlns:r="http://schemas.openxmlformats.org/officeDocument/2006/relationships" xmlns:p="http://schemas.openxmlformats.org/presentationml/2006/main">
   <p:cSld>
     <p:bg>
       <p:bgPr>
@@ -11379,7 +11568,14 @@
         <p:cNvGrpSpPr/>
         <p:nvPr/>
       </p:nvGrpSpPr>
-      <p:grpSpPr/>
+      <p:grpSpPr>
+        <a:xfrm>
+          <a:off x="0" y="0"/>
+          <a:ext cx="0" cy="0"/>
+          <a:chOff x="0" y="0"/>
+          <a:chExt cx="0" cy="0"/>
+        </a:xfrm>
+      </p:grpSpPr>
       <p:sp>
         <p:nvSpPr>
           <p:cNvPr id="2" name="TextBox 1"/>
@@ -11446,6 +11642,7 @@
                 <a:latin typeface="Segoe UI"/>
               </a:defRPr>
             </a:pPr>
+            <a:endParaRPr/>
           </a:p>
         </p:txBody>
       </p:sp>

</xml_diff>